<commit_message>
Polish Spanish pitch deck copy
</commit_message>
<xml_diff>
--- a/ArkScore-Pitch-Deck-ES.pptx
+++ b/ArkScore-Pitch-Deck-ES.pptx
@@ -1316,7 +1316,7 @@
                 <a:ea typeface="Aptos" pitchFamily="34" charset="-122"/>
                 <a:cs typeface="Aptos" pitchFamily="34" charset="-120"/>
               </a:rPr>
-              <a:t>LatAm Institucional Hackathon</a:t>
+              <a:t>Hackathon Institucional LatAm</a:t>
             </a:r>
             <a:endParaRPr lang="en-US" sz="750" dirty="0"/>
           </a:p>
@@ -2002,7 +2002,7 @@
                   <a:srgbClr val="2DE2A6"/>
                 </a:solidFill>
               </a:rPr>
-              <a:t>ORÁCULO DE CRÉDITO INSTITUCIONAL ON-CHAIN</a:t>
+              <a:t>ORÁCULO DE CRÉDITO INSTITUCIONAL EN CADENA</a:t>
             </a:r>
             <a:endParaRPr lang="en-US" sz="850" dirty="0"/>
           </a:p>
@@ -2078,7 +2078,7 @@
                   <a:srgbClr val="B8FFE6"/>
                 </a:solidFill>
               </a:rPr>
-              <a:t>Convierte riesgo de wallets en decisiones de crédito auditables para Arkangeles y Bankaool.</a:t>
+              <a:t>Convierte riesgo de billeteras en decisiones de crédito auditables para Arkangeles y Bankaool.</a:t>
             </a:r>
             <a:endParaRPr lang="en-US" sz="2500" dirty="0"/>
           </a:p>
@@ -2114,7 +2114,7 @@
                   <a:srgbClr val="9BB8AD"/>
                 </a:solidFill>
               </a:rPr>
-              <a:t>Wavy Node analiza trazabilidad · ArkScore calcula score 0-100 · Avalanche Fuji guarda la prueba</a:t>
+              <a:t>Wavy Node analiza trazabilidad · ArkScore calcula puntuación 0-100 · Avalanche Fuji guarda la prueba</a:t>
             </a:r>
             <a:endParaRPr lang="en-US" sz="1500" dirty="0"/>
           </a:p>
@@ -2206,7 +2206,7 @@
                   <a:srgbClr val="F3FFF9"/>
                 </a:solidFill>
               </a:rPr>
-              <a:t>Demo live</a:t>
+              <a:t>Demo en vivo</a:t>
             </a:r>
             <a:endParaRPr lang="en-US" sz="1500" dirty="0"/>
           </a:p>
@@ -2241,7 +2241,7 @@
                   <a:srgbClr val="9BB8AD"/>
                 </a:solidFill>
               </a:rPr>
-              <a:t>Frontend Vercel</a:t>
+              <a:t>Interfaz web en Vercel</a:t>
             </a:r>
             <a:endParaRPr lang="en-US" sz="1150" dirty="0"/>
           </a:p>
@@ -2252,7 +2252,7 @@
                   <a:srgbClr val="9BB8AD"/>
                 </a:solidFill>
               </a:rPr>
-              <a:t>API Railway</a:t>
+              <a:t>API en Railway</a:t>
             </a:r>
             <a:endParaRPr lang="en-US" sz="1150" dirty="0"/>
           </a:p>
@@ -2355,7 +2355,7 @@
                   <a:srgbClr val="F3FFF9"/>
                 </a:solidFill>
               </a:rPr>
-              <a:t>Prueba on-chain</a:t>
+              <a:t>Prueba en cadena</a:t>
             </a:r>
             <a:endParaRPr lang="en-US" sz="1500" dirty="0"/>
           </a:p>
@@ -2390,7 +2390,7 @@
                   <a:srgbClr val="9BB8AD"/>
                 </a:solidFill>
               </a:rPr>
-              <a:t>subjectHash + evidenceHash</a:t>
+              <a:t>hash del sujeto + hash de evidencia</a:t>
             </a:r>
             <a:endParaRPr lang="en-US" sz="1150" dirty="0"/>
           </a:p>
@@ -2401,7 +2401,7 @@
                   <a:srgbClr val="9BB8AD"/>
                 </a:solidFill>
               </a:rPr>
-              <a:t>score + decisión</a:t>
+              <a:t>puntuación + decisión</a:t>
             </a:r>
             <a:endParaRPr lang="en-US" sz="1150" dirty="0"/>
           </a:p>
@@ -2412,7 +2412,7 @@
                   <a:srgbClr val="9BB8AD"/>
                 </a:solidFill>
               </a:rPr>
-              <a:t>readback verificable</a:t>
+              <a:t>lectura verificable</a:t>
             </a:r>
             <a:endParaRPr lang="en-US" sz="1150" dirty="0"/>
           </a:p>
@@ -3176,7 +3176,7 @@
                   <a:srgbClr val="9BB8AD"/>
                 </a:solidFill>
               </a:rPr>
-              <a:t>Wallet risk, compliance y underwriting viven en sistemas separados.</a:t>
+              <a:t>Riesgo de billetera, cumplimiento y evaluación crediticia viven en sistemas separados.</a:t>
             </a:r>
             <a:endParaRPr lang="en-US" sz="1150" dirty="0"/>
           </a:p>
@@ -3436,7 +3436,7 @@
                   <a:srgbClr val="9BB8AD"/>
                 </a:solidFill>
               </a:rPr>
-              <a:t>Thin-file y crypto-native customers requieren señales alternativas sin perder compliance.</a:t>
+              <a:t>Clientes con poco historial y usuarios cripto requieren señales alternativas sin perder cumplimiento.</a:t>
             </a:r>
             <a:endParaRPr lang="en-US" sz="1150" dirty="0"/>
           </a:p>
@@ -3947,7 +3947,7 @@
                   <a:srgbClr val="B8FFE6"/>
                 </a:solidFill>
               </a:rPr>
-              <a:t>De wallet a decisión institucional en 3 pasos.</a:t>
+              <a:t>De billetera a decisión institucional en 3 pasos.</a:t>
             </a:r>
             <a:endParaRPr lang="en-US" sz="2200" dirty="0"/>
           </a:p>
@@ -4039,7 +4039,7 @@
                   <a:srgbClr val="F3FFF9"/>
                 </a:solidFill>
               </a:rPr>
-              <a:t>1 · Input</a:t>
+              <a:t>1 · Entrada</a:t>
             </a:r>
             <a:endParaRPr lang="en-US" sz="1500" dirty="0"/>
           </a:p>
@@ -4077,7 +4077,7 @@
                   <a:srgbClr val="9BB8AD"/>
                 </a:solidFill>
               </a:rPr>
-              <a:t>Wallet EVM + contexto institucional: Arkangeles o Bankaool.</a:t>
+              <a:t>Billetera EVM + contexto institucional: Arkangeles o Bankaool.</a:t>
             </a:r>
             <a:endParaRPr lang="en-US" sz="1150" dirty="0"/>
           </a:p>
@@ -4169,7 +4169,7 @@
                   <a:srgbClr val="F3FFF9"/>
                 </a:solidFill>
               </a:rPr>
-              <a:t>2 · Score</a:t>
+              <a:t>2 · Puntuación</a:t>
             </a:r>
             <a:endParaRPr lang="en-US" sz="1500" dirty="0"/>
           </a:p>
@@ -4207,7 +4207,7 @@
                   <a:srgbClr val="9BB8AD"/>
                 </a:solidFill>
               </a:rPr>
-              <a:t>Wavy risk + score compuesto ArkScore + bucket de decisión.</a:t>
+              <a:t>Riesgo Wavy + puntuación compuesta ArkScore + categoría de decisión.</a:t>
             </a:r>
             <a:endParaRPr lang="en-US" sz="1150" dirty="0"/>
           </a:p>
@@ -4299,7 +4299,7 @@
                   <a:srgbClr val="F3FFF9"/>
                 </a:solidFill>
               </a:rPr>
-              <a:t>3 · Proof</a:t>
+              <a:t>3 · Prueba</a:t>
             </a:r>
             <a:endParaRPr lang="en-US" sz="1500" dirty="0"/>
           </a:p>
@@ -4337,7 +4337,7 @@
                   <a:srgbClr val="9BB8AD"/>
                 </a:solidFill>
               </a:rPr>
-              <a:t>subjectHash, evidenceHash y registro verificable en Fuji.</a:t>
+              <a:t>Hash del sujeto, hash de evidencia y registro verificable en Fuji.</a:t>
             </a:r>
             <a:endParaRPr lang="en-US" sz="1150" dirty="0"/>
           </a:p>
@@ -4411,7 +4411,7 @@
                   <a:srgbClr val="9BB8AD"/>
                 </a:solidFill>
               </a:rPr>
-              <a:t>score crediticio</a:t>
+              <a:t>puntuación crediticia</a:t>
             </a:r>
             <a:endParaRPr lang="en-US" sz="850" dirty="0"/>
           </a:p>
@@ -4996,7 +4996,7 @@
                   <a:srgbClr val="2DE2A6"/>
                 </a:solidFill>
               </a:rPr>
-              <a:t>LINKS DE ENTREGA</a:t>
+              <a:t>ENLACES DE ENTREGA</a:t>
             </a:r>
             <a:endParaRPr lang="en-US" sz="850" dirty="0"/>
           </a:p>
@@ -5034,7 +5034,7 @@
                   <a:srgbClr val="F3FFF9"/>
                 </a:solidFill>
               </a:rPr>
-              <a:t>Demo live y evidencia</a:t>
+              <a:t>Demo en vivo y evidencia</a:t>
             </a:r>
             <a:endParaRPr lang="en-US" sz="3000" dirty="0"/>
           </a:p>
@@ -5126,7 +5126,7 @@
                   <a:srgbClr val="F3FFF9"/>
                 </a:solidFill>
               </a:rPr>
-              <a:t>Frontend</a:t>
+              <a:t>Interfaz web</a:t>
             </a:r>
             <a:endParaRPr lang="en-US" sz="1500" dirty="0"/>
           </a:p>
@@ -5256,7 +5256,7 @@
                   <a:srgbClr val="F3FFF9"/>
                 </a:solidFill>
               </a:rPr>
-              <a:t>Backend + OpenAPI</a:t>
+              <a:t>API + OpenAPI</a:t>
             </a:r>
             <a:endParaRPr lang="en-US" sz="1500" dirty="0"/>
           </a:p>
@@ -5641,7 +5641,7 @@
                   <a:srgbClr val="F3FFF9"/>
                 </a:solidFill>
               </a:rPr>
-              <a:t>Resultado demo</a:t>
+              <a:t>Resultado de demo</a:t>
             </a:r>
             <a:endParaRPr lang="en-US" sz="1800" dirty="0"/>
           </a:p>
@@ -5744,7 +5744,7 @@
                   <a:srgbClr val="B8FFE6"/>
                 </a:solidFill>
               </a:rPr>
-              <a:t>APPROVE_BANKAOOL_LOAN</a:t>
+              <a:t>APROBAR CRÉDITO BANKAOOL</a:t>
             </a:r>
             <a:endParaRPr lang="en-US" sz="850" dirty="0"/>
           </a:p>
@@ -5782,7 +5782,7 @@
                   <a:srgbClr val="9BB8AD"/>
                 </a:solidFill>
               </a:rPr>
-              <a:t>Mock Wavy risk 2/100 mientras tracker upstream de Wavy se recupera. El camino API → contrato → readback está probado end-to-end.</a:t>
+              <a:t>Riesgo Wavy simulado 2/100 mientras se recupera el rastreador de Wavy. La ruta API → contrato → lectura está probada de extremo a extremo.</a:t>
             </a:r>
             <a:endParaRPr lang="en-US" sz="1150" dirty="0"/>
           </a:p>
@@ -6443,7 +6443,7 @@
                   <a:srgbClr val="9BB8AD"/>
                 </a:solidFill>
               </a:rPr>
-              <a:t>Guarda score, decisión, institution, timestamp, submitter, subjectHash y evidenceHash.</a:t>
+              <a:t>Guarda puntuación, decisión, institución, marca de tiempo, remitente, hash del sujeto y hash de evidencia.</a:t>
             </a:r>
             <a:endParaRPr lang="en-US" sz="1150" dirty="0"/>
           </a:p>
@@ -6573,7 +6573,7 @@
                   <a:srgbClr val="9BB8AD"/>
                 </a:solidFill>
               </a:rPr>
-              <a:t>La wallet raw no se publica: se guarda un subjectHash derivado por backend.</a:t>
+              <a:t>La billetera original no se publica: se guarda un hash del sujeto derivado por backend.</a:t>
             </a:r>
             <a:endParaRPr lang="en-US" sz="1150" dirty="0"/>
           </a:p>
@@ -6703,7 +6703,7 @@
                   <a:srgbClr val="9BB8AD"/>
                 </a:solidFill>
               </a:rPr>
-              <a:t>Siguiente capa: notas crediticias o eligibility tokens confidenciales sin revelar detalles sensibles.</a:t>
+              <a:t>Siguiente capa: notas crediticias o tokens de elegibilidad confidenciales sin revelar detalles sensibles.</a:t>
             </a:r>
             <a:endParaRPr lang="en-US" sz="1150" dirty="0"/>
           </a:p>
@@ -7289,7 +7289,7 @@
                   <a:srgbClr val="9BB8AD"/>
                 </a:solidFill>
               </a:rPr>
-              <a:t>scan-risk para Avalanche 43114</a:t>
+              <a:t>análisis de riesgo para Avalanche 43114</a:t>
             </a:r>
             <a:endParaRPr lang="en-US" sz="1150" dirty="0"/>
           </a:p>
@@ -7416,7 +7416,7 @@
                   <a:srgbClr val="9BB8AD"/>
                 </a:solidFill>
               </a:rPr>
-              <a:t>provider, network, scan type</a:t>
+              <a:t>proveedor, red, tipo de análisis</a:t>
             </a:r>
             <a:endParaRPr lang="en-US" sz="1150" dirty="0"/>
           </a:p>
@@ -7427,7 +7427,7 @@
                   <a:srgbClr val="9BB8AD"/>
                 </a:solidFill>
               </a:rPr>
-              <a:t>risk scale, tx count</a:t>
+              <a:t>escala de riesgo, transacciones</a:t>
             </a:r>
             <a:endParaRPr lang="en-US" sz="1150" dirty="0"/>
           </a:p>
@@ -7438,7 +7438,7 @@
                   <a:srgbClr val="9BB8AD"/>
                 </a:solidFill>
               </a:rPr>
-              <a:t>patterns, analysis id</a:t>
+              <a:t>patrones, ID de análisis</a:t>
             </a:r>
             <a:endParaRPr lang="en-US" sz="1150" dirty="0"/>
           </a:p>
@@ -7568,7 +7568,7 @@
                   <a:srgbClr val="9BB8AD"/>
                 </a:solidFill>
               </a:rPr>
-              <a:t>Wavy evidence hash + analysis id quedan ligados a la decisión institucional.</a:t>
+              <a:t>El hash de evidencia Wavy y el ID de análisis quedan ligados a la decisión institucional.</a:t>
             </a:r>
             <a:endParaRPr lang="en-US" sz="1150" dirty="0"/>
           </a:p>
@@ -7631,7 +7631,7 @@
                   <a:srgbClr val="FFE7AC"/>
                 </a:solidFill>
               </a:rPr>
-              <a:t>Transparencia: la prueba enviada está marcada como mock porque Wavy upstream respondió tracker-service::analyze: fetch failed.</a:t>
+              <a:t>Transparencia: la prueba enviada está marcada como simulada porque el servicio de Wavy respondió tracker-service::analyze: fetch failed.</a:t>
             </a:r>
             <a:endParaRPr lang="en-US" sz="1100" dirty="0"/>
           </a:p>
@@ -7994,7 +7994,7 @@
                   <a:srgbClr val="2DE2A6"/>
                 </a:solidFill>
               </a:rPr>
-              <a:t>PER-QUERY SAAS</a:t>
+              <a:t>SAAS POR CONSULTA</a:t>
             </a:r>
             <a:endParaRPr lang="en-US" sz="850" dirty="0"/>
           </a:p>
@@ -8162,7 +8162,7 @@
                   <a:srgbClr val="9BB8AD"/>
                 </a:solidFill>
               </a:rPr>
-              <a:t>Crowdfunding, bancos digitales, lending desks, emisores de activos tokenizados y equipos compliance.</a:t>
+              <a:t>Plataformas de financiamiento, bancos digitales, mesas de crédito, emisores de activos tokenizados y equipos de cumplimiento.</a:t>
             </a:r>
             <a:endParaRPr lang="en-US" sz="1150" dirty="0"/>
           </a:p>
@@ -8254,7 +8254,7 @@
                   <a:srgbClr val="F3FFF9"/>
                 </a:solidFill>
               </a:rPr>
-              <a:t>Pricing</a:t>
+              <a:t>Modelo de cobro</a:t>
             </a:r>
             <a:endParaRPr lang="en-US" sz="1500" dirty="0"/>
           </a:p>
@@ -8292,7 +8292,7 @@
                   <a:srgbClr val="9BB8AD"/>
                 </a:solidFill>
               </a:rPr>
-              <a:t>Pago por wallet score, por prueba on-chain y planes enterprise para thresholds/reportes.</a:t>
+              <a:t>Pago por puntuación de billetera, por prueba en cadena y planes empresariales para umbrales/reportes.</a:t>
             </a:r>
             <a:endParaRPr lang="en-US" sz="1150" dirty="0"/>
           </a:p>
@@ -8422,7 +8422,7 @@
                   <a:srgbClr val="9BB8AD"/>
                 </a:solidFill>
               </a:rPr>
-              <a:t>Monitoreo recurrente, webhooks, batch scoring, reglas por institución y tokens privados eERC20.</a:t>
+              <a:t>Monitoreo recurrente, alertas webhook, puntuación por lote, reglas por institución y tokens privados eERC20.</a:t>
             </a:r>
             <a:endParaRPr lang="en-US" sz="1150" dirty="0"/>
           </a:p>
@@ -8552,7 +8552,7 @@
                   <a:srgbClr val="9BB8AD"/>
                 </a:solidFill>
               </a:rPr>
-              <a:t>LatAm fintech necesita underwriting crypto-aware con audit trail de nivel institucional.</a:t>
+              <a:t>Las fintech de LatAm necesitan evaluación crediticia cripto-consciente con trazabilidad auditable de nivel institucional.</a:t>
             </a:r>
             <a:endParaRPr lang="en-US" sz="1150" dirty="0"/>
           </a:p>
@@ -9045,7 +9045,7 @@
                   <a:srgbClr val="F3FFF9"/>
                 </a:solidFill>
               </a:rPr>
-              <a:t>Shipped</a:t>
+              <a:t>Entregado</a:t>
             </a:r>
             <a:endParaRPr lang="en-US" sz="1500" dirty="0"/>
           </a:p>
@@ -9080,7 +9080,7 @@
                   <a:srgbClr val="9BB8AD"/>
                 </a:solidFill>
               </a:rPr>
-              <a:t>Frontend Vercel</a:t>
+              <a:t>Interfaz web en Vercel</a:t>
             </a:r>
             <a:endParaRPr lang="en-US" sz="1150" dirty="0"/>
           </a:p>
@@ -9091,7 +9091,7 @@
                   <a:srgbClr val="9BB8AD"/>
                 </a:solidFill>
               </a:rPr>
-              <a:t>API Railway</a:t>
+              <a:t>API en Railway</a:t>
             </a:r>
             <a:endParaRPr lang="en-US" sz="1150" dirty="0"/>
           </a:p>
@@ -9240,7 +9240,7 @@
                   <a:srgbClr val="9BB8AD"/>
                 </a:solidFill>
               </a:rPr>
-              <a:t>Reactivar Wavy live cuando tracker-service se recupere</a:t>
+              <a:t>Reactivar Wavy en vivo cuando el rastreador se recupere</a:t>
             </a:r>
             <a:endParaRPr lang="en-US" sz="1150" dirty="0"/>
           </a:p>
@@ -9251,7 +9251,7 @@
                   <a:srgbClr val="9BB8AD"/>
                 </a:solidFill>
               </a:rPr>
-              <a:t>Correr record:fuji con score Wavy live</a:t>
+              <a:t>Ejecutar record:fuji con puntuación Wavy real</a:t>
             </a:r>
             <a:endParaRPr lang="en-US" sz="1150" dirty="0"/>
           </a:p>
@@ -9378,7 +9378,7 @@
                   <a:srgbClr val="9BB8AD"/>
                 </a:solidFill>
               </a:rPr>
-              <a:t>Arkangeles IFC screening</a:t>
+              <a:t>Evaluación Arkangeles IFC</a:t>
             </a:r>
             <a:endParaRPr lang="en-US" sz="1150" dirty="0"/>
           </a:p>
@@ -9389,7 +9389,7 @@
                   <a:srgbClr val="9BB8AD"/>
                 </a:solidFill>
               </a:rPr>
-              <a:t>Bankaool underwriting</a:t>
+              <a:t>Originación crediticia Bankaool</a:t>
             </a:r>
             <a:endParaRPr lang="en-US" sz="1150" dirty="0"/>
           </a:p>
@@ -9400,7 +9400,7 @@
                   <a:srgbClr val="9BB8AD"/>
                 </a:solidFill>
               </a:rPr>
-              <a:t>Configuración de thresholds por institución</a:t>
+              <a:t>Umbrales por institución</a:t>
             </a:r>
             <a:endParaRPr lang="en-US" sz="1150" dirty="0"/>
           </a:p>
@@ -9436,7 +9436,7 @@
                   <a:srgbClr val="2DE2A6"/>
                 </a:solidFill>
               </a:rPr>
-              <a:t>Ask</a:t>
+              <a:t>Solicitud</a:t>
             </a:r>
             <a:endParaRPr lang="en-US" sz="1600" dirty="0"/>
           </a:p>
@@ -9474,7 +9474,7 @@
                   <a:srgbClr val="F3FFF9"/>
                 </a:solidFill>
               </a:rPr>
-              <a:t>Validar ArkScore como rail institucional de scoring por consulta para crédito, inversión y compliance en LatAm.</a:t>
+              <a:t>Validar ArkScore como riel institucional de puntuación por consulta para crédito, inversión y cumplimiento en LatAm.</a:t>
             </a:r>
             <a:endParaRPr lang="en-US" sz="2200" dirty="0"/>
           </a:p>

</xml_diff>